<commit_message>
feat(deck): link the prototype walkthrough from the title slide
The deck carried no hyperlinks at all, so anyone who received it as a PDF
had no route to the working prototype. Slide 1 now ends with a walkthrough
link to the Google Drive folder holding the video and screens, plus the
live console and the source repository. Slide 6 repeats the same links in
the validation column, where a judge checking our claims will look.

PowerPoint paints hyperlinked runs with the theme's <a:hlink> colour and
ignores the colour set on the run, which rendered the links in the default
bright blue. fix_hyperlink_theme() repoints the master theme to the deck
navy so the links sit inside the existing palette.

Co-Authored-By: Claude Opus 5 (1M context) <noreply@anthropic.com>
</commit_message>
<xml_diff>
--- a/SIH2026-VIMAAN-SIH26056-BharatBytes.pptx
+++ b/SIH2026-VIMAAN-SIH26056-BharatBytes.pptx
@@ -6238,6 +6238,181 @@
           </a:p>
         </p:txBody>
       </p:sp>
+      <p:sp>
+        <p:nvSpPr>
+          <p:cNvPr id="47" name="Rectangle 46"/>
+          <p:cNvSpPr/>
+          <p:nvPr/>
+        </p:nvSpPr>
+        <p:spPr>
+          <a:xfrm>
+            <a:off x="329184" y="6089904"/>
+            <a:ext cx="5577840" cy="20320"/>
+          </a:xfrm>
+          <a:prstGeom prst="rect">
+            <a:avLst/>
+          </a:prstGeom>
+          <a:solidFill>
+            <a:srgbClr val="1F497D"/>
+          </a:solidFill>
+          <a:ln>
+            <a:noFill/>
+          </a:ln>
+          <a:effectLst/>
+        </p:spPr>
+        <p:style>
+          <a:lnRef idx="1">
+            <a:schemeClr val="accent1"/>
+          </a:lnRef>
+          <a:fillRef idx="3">
+            <a:schemeClr val="accent1"/>
+          </a:fillRef>
+          <a:effectRef idx="2">
+            <a:schemeClr val="accent1"/>
+          </a:effectRef>
+          <a:fontRef idx="minor">
+            <a:schemeClr val="lt1"/>
+          </a:fontRef>
+        </p:style>
+        <p:txBody>
+          <a:bodyPr rtlCol="0" anchor="ctr"/>
+          <a:lstStyle/>
+          <a:p>
+            <a:pPr algn="ctr"/>
+          </a:p>
+        </p:txBody>
+      </p:sp>
+      <p:sp>
+        <p:nvSpPr>
+          <p:cNvPr id="48" name="TextBox 47"/>
+          <p:cNvSpPr txBox="1"/>
+          <p:nvPr/>
+        </p:nvSpPr>
+        <p:spPr>
+          <a:xfrm>
+            <a:off x="329184" y="6153912"/>
+            <a:ext cx="5577840" cy="237744"/>
+          </a:xfrm>
+          <a:prstGeom prst="rect">
+            <a:avLst/>
+          </a:prstGeom>
+          <a:noFill/>
+          <a:effectLst/>
+        </p:spPr>
+        <p:txBody>
+          <a:bodyPr wrap="square" anchor="t" lIns="0" rIns="0" tIns="0" bIns="0">
+            <a:spAutoFit/>
+          </a:bodyPr>
+          <a:lstStyle/>
+          <a:p>
+            <a:pPr algn="l">
+              <a:lnSpc>
+                <a:spcPct val="106000"/>
+              </a:lnSpc>
+              <a:spcBef>
+                <a:spcPts val="0"/>
+              </a:spcBef>
+              <a:spcAft>
+                <a:spcPts val="200"/>
+              </a:spcAft>
+            </a:pPr>
+            <a:r>
+              <a:rPr sz="760" b="1" i="0">
+                <a:solidFill>
+                  <a:srgbClr val="B86B00"/>
+                </a:solidFill>
+                <a:latin typeface="Arial"/>
+              </a:rPr>
+              <a:t>WALKTHROUGH  </a:t>
+            </a:r>
+            <a:r>
+              <a:rPr sz="900" b="1" i="0">
+                <a:solidFill>
+                  <a:srgbClr val="1F497D"/>
+                </a:solidFill>
+                <a:latin typeface="Arial"/>
+                <a:hlinkClick r:id="rId5"/>
+              </a:rPr>
+              <a:t>Prototype video and screens on Google Drive</a:t>
+            </a:r>
+          </a:p>
+        </p:txBody>
+      </p:sp>
+      <p:sp>
+        <p:nvSpPr>
+          <p:cNvPr id="49" name="TextBox 48"/>
+          <p:cNvSpPr txBox="1"/>
+          <p:nvPr/>
+        </p:nvSpPr>
+        <p:spPr>
+          <a:xfrm>
+            <a:off x="329184" y="6419088"/>
+            <a:ext cx="5577840" cy="237744"/>
+          </a:xfrm>
+          <a:prstGeom prst="rect">
+            <a:avLst/>
+          </a:prstGeom>
+          <a:noFill/>
+          <a:effectLst/>
+        </p:spPr>
+        <p:txBody>
+          <a:bodyPr wrap="square" anchor="t" lIns="0" rIns="0" tIns="0" bIns="0">
+            <a:spAutoFit/>
+          </a:bodyPr>
+          <a:lstStyle/>
+          <a:p>
+            <a:pPr algn="l">
+              <a:lnSpc>
+                <a:spcPct val="106000"/>
+              </a:lnSpc>
+              <a:spcBef>
+                <a:spcPts val="0"/>
+              </a:spcBef>
+              <a:spcAft>
+                <a:spcPts val="200"/>
+              </a:spcAft>
+            </a:pPr>
+            <a:r>
+              <a:rPr sz="720" b="1" i="0">
+                <a:solidFill>
+                  <a:srgbClr val="B86B00"/>
+                </a:solidFill>
+                <a:latin typeface="Arial"/>
+              </a:rPr>
+              <a:t>LIVE  </a:t>
+            </a:r>
+            <a:r>
+              <a:rPr sz="800" b="0" i="0">
+                <a:solidFill>
+                  <a:srgbClr val="1F497D"/>
+                </a:solidFill>
+                <a:latin typeface="Arial"/>
+                <a:hlinkClick r:id="rId6"/>
+              </a:rPr>
+              <a:t>vimaan-console.vercel.app</a:t>
+            </a:r>
+            <a:r>
+              <a:rPr sz="720" b="1" i="0">
+                <a:solidFill>
+                  <a:srgbClr val="B86B00"/>
+                </a:solidFill>
+                <a:latin typeface="Arial"/>
+              </a:rPr>
+              <a:t>        SOURCE  </a:t>
+            </a:r>
+            <a:r>
+              <a:rPr sz="800" b="0" i="0">
+                <a:solidFill>
+                  <a:srgbClr val="1F497D"/>
+                </a:solidFill>
+                <a:latin typeface="Arial"/>
+                <a:hlinkClick r:id="rId7"/>
+              </a:rPr>
+              <a:t>github.com/hersheysss3/vimaan-airfare-index</a:t>
+            </a:r>
+          </a:p>
+        </p:txBody>
+      </p:sp>
     </p:spTree>
   </p:cSld>
   <p:clrMapOvr>
@@ -18664,6 +18839,81 @@
           <a:lstStyle/>
           <a:p>
             <a:pPr algn="ctr"/>
+          </a:p>
+        </p:txBody>
+      </p:sp>
+      <p:sp>
+        <p:nvSpPr>
+          <p:cNvPr id="17463" name="TextBox 17462"/>
+          <p:cNvSpPr txBox="1"/>
+          <p:nvPr/>
+        </p:nvSpPr>
+        <p:spPr>
+          <a:xfrm>
+            <a:off x="8129016" y="5966460"/>
+            <a:ext cx="3739896" cy="219456"/>
+          </a:xfrm>
+          <a:prstGeom prst="rect">
+            <a:avLst/>
+          </a:prstGeom>
+          <a:noFill/>
+          <a:effectLst/>
+        </p:spPr>
+        <p:txBody>
+          <a:bodyPr wrap="square" anchor="t" lIns="0" rIns="0" tIns="0" bIns="0">
+            <a:spAutoFit/>
+          </a:bodyPr>
+          <a:lstStyle/>
+          <a:p>
+            <a:pPr algn="l">
+              <a:lnSpc>
+                <a:spcPct val="102000"/>
+              </a:lnSpc>
+              <a:spcBef>
+                <a:spcPts val="0"/>
+              </a:spcBef>
+              <a:spcAft>
+                <a:spcPts val="200"/>
+              </a:spcAft>
+            </a:pPr>
+            <a:r>
+              <a:rPr sz="720" b="1" i="0">
+                <a:solidFill>
+                  <a:srgbClr val="1B7A3C"/>
+                </a:solidFill>
+                <a:latin typeface="Arial"/>
+              </a:rPr>
+              <a:t>SEE IT RUN  </a:t>
+            </a:r>
+            <a:r>
+              <a:rPr sz="740" b="1" i="0">
+                <a:solidFill>
+                  <a:srgbClr val="1F497D"/>
+                </a:solidFill>
+                <a:latin typeface="Arial"/>
+                <a:hlinkClick r:id="rId4"/>
+              </a:rPr>
+              <a:t>walkthrough</a:t>
+            </a:r>
+            <a:r>
+              <a:rPr sz="740" b="0" i="0">
+                <a:solidFill>
+                  <a:srgbClr val="8A93A2"/>
+                </a:solidFill>
+                <a:latin typeface="Arial"/>
+              </a:rPr>
+              <a:t>  ·  </a:t>
+            </a:r>
+            <a:r>
+              <a:rPr sz="740" b="0" i="0">
+                <a:solidFill>
+                  <a:srgbClr val="1F497D"/>
+                </a:solidFill>
+                <a:latin typeface="Arial"/>
+                <a:hlinkClick r:id="rId5"/>
+              </a:rPr>
+              <a:t>vimaan-console.vercel.app</a:t>
+            </a:r>
           </a:p>
         </p:txBody>
       </p:sp>
@@ -18715,10 +18965,10 @@
         <a:srgbClr val="F79646"/>
       </a:accent6>
       <a:hlink>
-        <a:srgbClr val="0000FF"/>
+        <a:srgbClr val="1F497D"/>
       </a:hlink>
       <a:folHlink>
-        <a:srgbClr val="800080"/>
+        <a:srgbClr val="1F497D"/>
       </a:folHlink>
     </a:clrScheme>
     <a:fontScheme name="Office">

</xml_diff>